<commit_message>
Gastro im ganzen EG (460 m²), Gastro-Konzept-Präsentation, neue Gastro- und Außenbilder
Co-Authored-By: Claude Sonnet 5.5 <noreply@anthropic.com>
Claude-Session: https://claude.ai/code/session_01HJGZfxHv7bzYyqdLwg8aFJ
</commit_message>
<xml_diff>
--- a/praesentation/Neue-Mitte-Werlte_Baufeld3_Optionen-Dauermiete-Airbnb-Hotel.pptx
+++ b/praesentation/Neue-Mitte-Werlte_Baufeld3_Optionen-Dauermiete-Airbnb-Hotel.pptx
@@ -776,7 +776,7 @@
           <a:p>
             <a:r>
               <a:rPr lang="en-US" dirty="0"/>
-              <a:t>Variante B: 540 m² Grundfläche, 1.540 m² BGF. Gastro (290 m²) und Büro (150 m²) im EG sind in allen Optionen gleich. 3,3 % Zins, 1 % Tilgung, ohne Förderung, ohne Lohn des Bauherrn.</a:t>
+              <a:t>Variante B: 540 m² Grundfläche, 1.540 m² BGF. Die Gastro (460 m²) im ganzen EG ist in allen Optionen gleich. 3,3 % Zins, 1 % Tilgung, ohne Förderung, ohne Lohn des Bauherrn.</a:t>
             </a:r>
             <a:endParaRPr lang="en-US" dirty="0"/>
           </a:p>
@@ -864,7 +864,7 @@
           <a:p>
             <a:r>
               <a:rPr lang="en-US" dirty="0"/>
-              <a:t>Ausführliche Rechnung steht in der Hauptpräsentation (8 Wohnungen und Büro, Gastro im EG).</a:t>
+              <a:t>Ausführliche Rechnung steht in der Hauptpräsentation (8 Wohnungen, Gastro im EG).</a:t>
             </a:r>
             <a:endParaRPr lang="en-US" dirty="0"/>
           </a:p>
@@ -1304,7 +1304,7 @@
           <a:p>
             <a:r>
               <a:rPr lang="en-US" dirty="0"/>
-              <a:t>Ergebnis des ganzen Hauses pro Monat: Gastro und Büro plus Hotel minus Rate (17.282 €). Gleichauf mit der Dauermiete ab ca. 51 % Auslastung (Eigenbetrieb).</a:t>
+              <a:t>Ergebnis des ganzen Hauses pro Monat: Gastro plus Hotel minus Rate (17.282 €). Gleichauf mit der Dauermiete ab ca. 51 % Auslastung (Eigenbetrieb).</a:t>
             </a:r>
             <a:endParaRPr lang="en-US" dirty="0"/>
           </a:p>
@@ -2501,7 +2501,7 @@
                 <a:ea typeface="Arial" pitchFamily="34" charset="-122"/>
                 <a:cs typeface="Arial" pitchFamily="34" charset="-120"/>
               </a:rPr>
-              <a:t>Im Mischgebiet sind Wohnen, Beherbergung und Büro meist zulässig, die Stadt muss es für Baufeld 3 und die 540 m² Grundfläche bestätigen.</a:t>
+              <a:t>Im Mischgebiet sind Wohnen, Beherbergung und Gastro meist zulässig, die Stadt muss es für Baufeld 3 und die 540 m² Grundfläche bestätigen.</a:t>
             </a:r>
             <a:endParaRPr lang="en-US" sz="1300" dirty="0"/>
           </a:p>
@@ -2920,7 +2920,7 @@
                 <a:ea typeface="Arial" pitchFamily="34" charset="-122"/>
                 <a:cs typeface="Arial" pitchFamily="34" charset="-120"/>
               </a:rPr>
-              <a:t>Dauermiete (+7.905 € pro Monat) ist die beste Option: Airbnb (+4.228 €) liegt klar darunter, das Hotel (+8.004 € bei 52 % Auslastung, Eigenbetrieb) nur gleichauf, dafür mit viel mehr Aufwand, Zusatzkredit und Brandschutzauflagen.</a:t>
+              <a:t>Dauermiete (+6.351 € pro Monat) ist die beste Option: Airbnb (+2.674 €) liegt klar darunter, das Hotel (+6.450 € bei 52 % Auslastung, Eigenbetrieb) nur gleichauf, dafür mit viel mehr Aufwand, Zusatzkredit und Brandschutzauflagen.</a:t>
             </a:r>
             <a:endParaRPr lang="en-US" sz="1600" dirty="0"/>
           </a:p>
@@ -3894,7 +3894,7 @@
                           <a:ea typeface="Arial" pitchFamily="34" charset="-122"/>
                           <a:cs typeface="Arial" pitchFamily="34" charset="-120"/>
                         </a:rPr>
-                        <a:t>+7.905 €</a:t>
+                        <a:t>+6.351 €</a:t>
                       </a:r>
                       <a:endParaRPr lang="en-US" sz="1250" dirty="0">
                         <a:latin typeface="Arial" charset="0"/>
@@ -4289,7 +4289,7 @@
                           <a:ea typeface="Arial" pitchFamily="34" charset="-122"/>
                           <a:cs typeface="Arial" pitchFamily="34" charset="-120"/>
                         </a:rPr>
-                        <a:t>+4.228 €</a:t>
+                        <a:t>+2.674 €</a:t>
                       </a:r>
                       <a:endParaRPr lang="en-US" sz="1250" dirty="0">
                         <a:latin typeface="Arial" charset="0"/>
@@ -4684,7 +4684,7 @@
                           <a:ea typeface="Arial" pitchFamily="34" charset="-122"/>
                           <a:cs typeface="Arial" pitchFamily="34" charset="-120"/>
                         </a:rPr>
-                        <a:t>+8.004 €</a:t>
+                        <a:t>+6.450 €</a:t>
                       </a:r>
                       <a:endParaRPr lang="en-US" sz="1250" dirty="0">
                         <a:latin typeface="Arial" charset="0"/>
@@ -5079,7 +5079,7 @@
                           <a:ea typeface="Arial" pitchFamily="34" charset="-122"/>
                           <a:cs typeface="Arial" pitchFamily="34" charset="-120"/>
                         </a:rPr>
-                        <a:t>+5.358 €</a:t>
+                        <a:t>+3.804 €</a:t>
                       </a:r>
                       <a:endParaRPr lang="en-US" sz="1250" dirty="0">
                         <a:latin typeface="Arial" charset="0"/>
@@ -5516,7 +5516,7 @@
       </p:sp>
       <p:sp>
         <p:nvSpPr>
-          <p:cNvPr id="8" name="Kennzahl Kaltmiete pro Monat (11,18 €/m², Büro 10 €/m²)"/>
+          <p:cNvPr id="8" name="Kennzahl Kaltmiete pro Monat (11,18 €/m²)"/>
           <p:cNvSpPr/>
           <p:nvPr/>
         </p:nvSpPr>
@@ -5574,7 +5574,7 @@
                 <a:ea typeface="Georgia" pitchFamily="34" charset="-122"/>
                 <a:cs typeface="Georgia" pitchFamily="34" charset="-120"/>
               </a:rPr>
-              <a:t>9.603 €</a:t>
+              <a:t>8.103 €</a:t>
             </a:r>
             <a:endParaRPr lang="en-US" sz="2800" dirty="0"/>
           </a:p>
@@ -5613,7 +5613,7 @@
                 <a:ea typeface="Arial" pitchFamily="34" charset="-122"/>
                 <a:cs typeface="Arial" pitchFamily="34" charset="-120"/>
               </a:rPr>
-              <a:t>Kaltmiete pro Monat (11,18 €/m², Büro 10 €/m²)</a:t>
+              <a:t>Kaltmiete pro Monat (11,18 €/m²)</a:t>
             </a:r>
             <a:endParaRPr lang="en-US" sz="1300" dirty="0"/>
           </a:p>
@@ -5784,7 +5784,7 @@
                 <a:ea typeface="Georgia" pitchFamily="34" charset="-122"/>
                 <a:cs typeface="Georgia" pitchFamily="34" charset="-120"/>
               </a:rPr>
-              <a:t>+7.905 €</a:t>
+              <a:t>+6.351 €</a:t>
             </a:r>
             <a:endParaRPr lang="en-US" sz="2800" dirty="0"/>
           </a:p>
@@ -9031,7 +9031,7 @@
                           <a:ea typeface="Arial" pitchFamily="34" charset="-122"/>
                           <a:cs typeface="Arial" pitchFamily="34" charset="-120"/>
                         </a:rPr>
-                        <a:t>+3.057 €</a:t>
+                        <a:t>+1.503 €</a:t>
                       </a:r>
                       <a:endParaRPr lang="en-US" sz="1250" dirty="0">
                         <a:latin typeface="Arial" charset="0"/>
@@ -9296,7 +9296,7 @@
                           <a:ea typeface="Arial" pitchFamily="34" charset="-122"/>
                           <a:cs typeface="Arial" pitchFamily="34" charset="-120"/>
                         </a:rPr>
-                        <a:t>+4.228 €</a:t>
+                        <a:t>+2.674 €</a:t>
                       </a:r>
                       <a:endParaRPr lang="en-US" sz="1250" dirty="0">
                         <a:latin typeface="Arial" charset="0"/>
@@ -9561,7 +9561,7 @@
                           <a:ea typeface="Arial" pitchFamily="34" charset="-122"/>
                           <a:cs typeface="Arial" pitchFamily="34" charset="-120"/>
                         </a:rPr>
-                        <a:t>+5.399 €</a:t>
+                        <a:t>+3.845 €</a:t>
                       </a:r>
                       <a:endParaRPr lang="en-US" sz="1250" dirty="0">
                         <a:latin typeface="Arial" charset="0"/>
@@ -9826,7 +9826,7 @@
                           <a:ea typeface="Arial" pitchFamily="34" charset="-122"/>
                           <a:cs typeface="Arial" pitchFamily="34" charset="-120"/>
                         </a:rPr>
-                        <a:t>+6.570 €</a:t>
+                        <a:t>+5.016 €</a:t>
                       </a:r>
                       <a:endParaRPr lang="en-US" sz="1250" dirty="0">
                         <a:latin typeface="Arial" charset="0"/>
@@ -10091,7 +10091,7 @@
                           <a:ea typeface="Arial" pitchFamily="34" charset="-122"/>
                           <a:cs typeface="Arial" pitchFamily="34" charset="-120"/>
                         </a:rPr>
-                        <a:t>+7.741 €</a:t>
+                        <a:t>+6.187 €</a:t>
                       </a:r>
                       <a:endParaRPr lang="en-US" sz="1250" dirty="0">
                         <a:latin typeface="Arial" charset="0"/>
@@ -10356,7 +10356,7 @@
                           <a:ea typeface="Arial" pitchFamily="34" charset="-122"/>
                           <a:cs typeface="Arial" pitchFamily="34" charset="-120"/>
                         </a:rPr>
-                        <a:t>+8.912 €</a:t>
+                        <a:t>+7.358 €</a:t>
                       </a:r>
                       <a:endParaRPr lang="en-US" sz="1250" dirty="0">
                         <a:latin typeface="Arial" charset="0"/>
@@ -11247,7 +11247,7 @@
                           <a:ea typeface="Arial" pitchFamily="34" charset="-122"/>
                           <a:cs typeface="Arial" pitchFamily="34" charset="-120"/>
                         </a:rPr>
-                        <a:t>+3.174 €</a:t>
+                        <a:t>+1.620 €</a:t>
                       </a:r>
                       <a:endParaRPr lang="en-US" sz="1250" dirty="0">
                         <a:latin typeface="Arial" charset="0"/>
@@ -11577,7 +11577,7 @@
                           <a:ea typeface="Arial" pitchFamily="34" charset="-122"/>
                           <a:cs typeface="Arial" pitchFamily="34" charset="-120"/>
                         </a:rPr>
-                        <a:t>+4.228 €</a:t>
+                        <a:t>+2.674 €</a:t>
                       </a:r>
                       <a:endParaRPr lang="en-US" sz="1250" dirty="0">
                         <a:latin typeface="Arial" charset="0"/>
@@ -11907,7 +11907,7 @@
                           <a:ea typeface="Arial" pitchFamily="34" charset="-122"/>
                           <a:cs typeface="Arial" pitchFamily="34" charset="-120"/>
                         </a:rPr>
-                        <a:t>+5.282 €</a:t>
+                        <a:t>+3.728 €</a:t>
                       </a:r>
                       <a:endParaRPr lang="en-US" sz="1250" dirty="0">
                         <a:latin typeface="Arial" charset="0"/>
@@ -12237,7 +12237,7 @@
                           <a:ea typeface="Arial" pitchFamily="34" charset="-122"/>
                           <a:cs typeface="Arial" pitchFamily="34" charset="-120"/>
                         </a:rPr>
-                        <a:t>+6.336 €</a:t>
+                        <a:t>+4.782 €</a:t>
                       </a:r>
                       <a:endParaRPr lang="en-US" sz="1250" dirty="0">
                         <a:latin typeface="Arial" charset="0"/>
@@ -14885,7 +14885,7 @@
                           <a:ea typeface="Arial" pitchFamily="34" charset="-122"/>
                           <a:cs typeface="Arial" pitchFamily="34" charset="-120"/>
                         </a:rPr>
-                        <a:t>+5.919 €</a:t>
+                        <a:t>+4.365 €</a:t>
                       </a:r>
                       <a:endParaRPr lang="en-US" sz="1250" dirty="0">
                         <a:latin typeface="Arial" charset="0"/>
@@ -15018,7 +15018,7 @@
                           <a:ea typeface="Arial" pitchFamily="34" charset="-122"/>
                           <a:cs typeface="Arial" pitchFamily="34" charset="-120"/>
                         </a:rPr>
-                        <a:t>+3.884 €</a:t>
+                        <a:t>+2.330 €</a:t>
                       </a:r>
                       <a:endParaRPr lang="en-US" sz="1250" dirty="0">
                         <a:latin typeface="Arial" charset="0"/>
@@ -15283,7 +15283,7 @@
                           <a:ea typeface="Arial" pitchFamily="34" charset="-122"/>
                           <a:cs typeface="Arial" pitchFamily="34" charset="-120"/>
                         </a:rPr>
-                        <a:t>+7.657 €</a:t>
+                        <a:t>+6.103 €</a:t>
                       </a:r>
                       <a:endParaRPr lang="en-US" sz="1250" dirty="0">
                         <a:latin typeface="Arial" charset="0"/>
@@ -15416,7 +15416,7 @@
                           <a:ea typeface="Arial" pitchFamily="34" charset="-122"/>
                           <a:cs typeface="Arial" pitchFamily="34" charset="-120"/>
                         </a:rPr>
-                        <a:t>+5.113 €</a:t>
+                        <a:t>+3.559 €</a:t>
                       </a:r>
                       <a:endParaRPr lang="en-US" sz="1250" dirty="0">
                         <a:latin typeface="Arial" charset="0"/>
@@ -15681,7 +15681,7 @@
                           <a:ea typeface="Arial" pitchFamily="34" charset="-122"/>
                           <a:cs typeface="Arial" pitchFamily="34" charset="-120"/>
                         </a:rPr>
-                        <a:t>+9.394 €</a:t>
+                        <a:t>+7.840 €</a:t>
                       </a:r>
                       <a:endParaRPr lang="en-US" sz="1250" dirty="0">
                         <a:latin typeface="Arial" charset="0"/>
@@ -15814,7 +15814,7 @@
                           <a:ea typeface="Arial" pitchFamily="34" charset="-122"/>
                           <a:cs typeface="Arial" pitchFamily="34" charset="-120"/>
                         </a:rPr>
-                        <a:t>+6.341 €</a:t>
+                        <a:t>+4.787 €</a:t>
                       </a:r>
                       <a:endParaRPr lang="en-US" sz="1250" dirty="0">
                         <a:latin typeface="Arial" charset="0"/>
@@ -16079,7 +16079,7 @@
                           <a:ea typeface="Arial" pitchFamily="34" charset="-122"/>
                           <a:cs typeface="Arial" pitchFamily="34" charset="-120"/>
                         </a:rPr>
-                        <a:t>+11.131 €</a:t>
+                        <a:t>+9.577 €</a:t>
                       </a:r>
                       <a:endParaRPr lang="en-US" sz="1250" dirty="0">
                         <a:latin typeface="Arial" charset="0"/>
@@ -16212,7 +16212,7 @@
                           <a:ea typeface="Arial" pitchFamily="34" charset="-122"/>
                           <a:cs typeface="Arial" pitchFamily="34" charset="-120"/>
                         </a:rPr>
-                        <a:t>+7.570 €</a:t>
+                        <a:t>+6.016 €</a:t>
                       </a:r>
                       <a:endParaRPr lang="en-US" sz="1250" dirty="0">
                         <a:latin typeface="Arial" charset="0"/>
@@ -16401,7 +16401,7 @@
                           <a:ea typeface="Arial" pitchFamily="34" charset="-122"/>
                           <a:cs typeface="Arial" pitchFamily="34" charset="-120"/>
                         </a:rPr>
-                        <a:t>8.643 €</a:t>
+                        <a:t>7.293 €</a:t>
                       </a:r>
                       <a:endParaRPr lang="en-US" sz="1250" dirty="0">
                         <a:latin typeface="Arial" charset="0"/>
@@ -16466,7 +16466,7 @@
                           <a:ea typeface="Arial" pitchFamily="34" charset="-122"/>
                           <a:cs typeface="Arial" pitchFamily="34" charset="-120"/>
                         </a:rPr>
-                        <a:t>+7.905 €</a:t>
+                        <a:t>+6.351 €</a:t>
                       </a:r>
                       <a:endParaRPr lang="en-US" sz="1250" dirty="0">
                         <a:latin typeface="Arial" charset="0"/>
@@ -17080,7 +17080,7 @@
                           <a:ea typeface="Arial" pitchFamily="34" charset="-122"/>
                           <a:cs typeface="Arial" pitchFamily="34" charset="-120"/>
                         </a:rPr>
-                        <a:t>+6.941 €</a:t>
+                        <a:t>+5.387 €</a:t>
                       </a:r>
                       <a:endParaRPr lang="en-US" sz="1250" dirty="0">
                         <a:latin typeface="Arial" charset="0"/>
@@ -17345,7 +17345,7 @@
                           <a:ea typeface="Arial" pitchFamily="34" charset="-122"/>
                           <a:cs typeface="Arial" pitchFamily="34" charset="-120"/>
                         </a:rPr>
-                        <a:t>+8.004 €</a:t>
+                        <a:t>+6.450 €</a:t>
                       </a:r>
                       <a:endParaRPr lang="en-US" sz="1250" dirty="0">
                         <a:latin typeface="Arial" charset="0"/>
@@ -17610,7 +17610,7 @@
                           <a:ea typeface="Arial" pitchFamily="34" charset="-122"/>
                           <a:cs typeface="Arial" pitchFamily="34" charset="-120"/>
                         </a:rPr>
-                        <a:t>+9.067 €</a:t>
+                        <a:t>+7.513 €</a:t>
                       </a:r>
                       <a:endParaRPr lang="en-US" sz="1250" dirty="0">
                         <a:latin typeface="Arial" charset="0"/>
@@ -17875,7 +17875,7 @@
                           <a:ea typeface="Arial" pitchFamily="34" charset="-122"/>
                           <a:cs typeface="Arial" pitchFamily="34" charset="-120"/>
                         </a:rPr>
-                        <a:t>+10.130 €</a:t>
+                        <a:t>+8.576 €</a:t>
                       </a:r>
                       <a:endParaRPr lang="en-US" sz="1250" dirty="0">
                         <a:latin typeface="Arial" charset="0"/>
@@ -20992,7 +20992,7 @@
                 <a:ea typeface="Arial" pitchFamily="34" charset="-122"/>
                 <a:cs typeface="Arial" pitchFamily="34" charset="-120"/>
               </a:rPr>
-              <a:t>Nur bei Dauermiete liegt der Preis für +250 € nahe an den Selbstkosten, die Differenz von 697.503 € trägst du (Dein Ergebnis dann +8.475 € pro Monat). Bei Airbnb wären es 1.824.923 € und beim Hotel 2.808.039 €.</a:t>
+              <a:t>Nur bei Dauermiete liegt der Preis für +250 € nahe an den Selbstkosten, die Differenz von 697.503 € trägst du (Dein Ergebnis dann +7.125 € pro Monat). Bei Airbnb wären es 1.824.923 € und beim Hotel 2.808.039 €.</a:t>
             </a:r>
             <a:endParaRPr lang="en-US" sz="1300" dirty="0"/>
           </a:p>

</xml_diff>